<commit_message>
Mettre à jour les guides utilisateurs (Clients, Schéma, Bon de livraison)
Guide-ChargeDesCommandes.pptx (+2 diapositives) : nouvel écran Clients
(/commandes/clients — liste, recherche, modifier) et l'assignation
d'une zone de dépôt à un Dépositaire.

Guide-ResponsableProduction.pptx (+3 diapositives) : zones de dépôt,
Schéma de commande (alimentation automatique du Planning) et Bon de
livraison (saisie indépendante + export PDF avec lignes de signature).

Captures d'écran réelles prises sur l'application (rôles Chargé des
commandes et Responsable de production), pagination et récapitulatifs
mis à jour en conséquence.

Co-Authored-By: Claude Sonnet 5 <noreply@anthropic.com>
Claude-Session: https://claude.ai/code/session_01FbLPDP6PAYDFWjK11AfFVb
</commit_message>
<xml_diff>
--- a/docs/guides-utilisateurs/Guide-ChargeDesCommandes.pptx
+++ b/docs/guides-utilisateurs/Guide-ChargeDesCommandes.pptx
@@ -13,6 +13,8 @@
     <p:sldId id="261" r:id="rId7"/>
     <p:sldId id="262" r:id="rId8"/>
     <p:sldId id="263" r:id="rId9"/>
+    <p:sldId id="270" r:id="rId21"/>
+    <p:sldId id="271" r:id="rId22"/>
     <p:sldId id="264" r:id="rId10"/>
     <p:sldId id="265" r:id="rId11"/>
     <p:sldId id="266" r:id="rId12"/>
@@ -2714,7 +2716,7 @@
                 <a:ea typeface="Calibri" pitchFamily="34" charset="-122"/>
                 <a:cs typeface="Calibri" pitchFamily="34" charset="-120"/>
               </a:rPr>
-              <a:t>10 / 14</a:t>
+              <a:t>12 / 16</a:t>
             </a:r>
             <a:endParaRPr lang="en-US" sz="950" dirty="0"/>
           </a:p>
@@ -3146,7 +3148,7 @@
                 <a:ea typeface="Calibri" pitchFamily="34" charset="-122"/>
                 <a:cs typeface="Calibri" pitchFamily="34" charset="-120"/>
               </a:rPr>
-              <a:t>11 / 14</a:t>
+              <a:t>13 / 16</a:t>
             </a:r>
             <a:endParaRPr lang="en-US" sz="950" dirty="0"/>
           </a:p>
@@ -3578,7 +3580,7 @@
                 <a:ea typeface="Calibri" pitchFamily="34" charset="-122"/>
                 <a:cs typeface="Calibri" pitchFamily="34" charset="-120"/>
               </a:rPr>
-              <a:t>12 / 14</a:t>
+              <a:t>14 / 16</a:t>
             </a:r>
             <a:endParaRPr lang="en-US" sz="950" dirty="0"/>
           </a:p>
@@ -5025,7 +5027,7 @@
                 <a:ea typeface="Calibri" pitchFamily="34" charset="-122"/>
                 <a:cs typeface="Calibri" pitchFamily="34" charset="-120"/>
               </a:rPr>
-              <a:t>13 / 14</a:t>
+              <a:t>15 / 16</a:t>
             </a:r>
             <a:endParaRPr lang="en-US" sz="950" dirty="0"/>
           </a:p>
@@ -5299,7 +5301,7 @@
                 <a:ea typeface="Calibri" pitchFamily="34" charset="-122"/>
                 <a:cs typeface="Calibri" pitchFamily="34" charset="-120"/>
               </a:rPr>
-              <a:t>14 / 14</a:t>
+              <a:t>16 / 16</a:t>
             </a:r>
             <a:endParaRPr lang="en-US" sz="950" dirty="0"/>
           </a:p>
@@ -5333,6 +5335,992 @@
               <a:rPr lang="en-US" sz="950" dirty="0">
                 <a:solidFill>
                   <a:srgbClr val="6B7684"/>
+                </a:solidFill>
+                <a:latin typeface="Calibri" pitchFamily="34" charset="0"/>
+                <a:ea typeface="Calibri" pitchFamily="34" charset="-122"/>
+                <a:cs typeface="Calibri" pitchFamily="34" charset="-120"/>
+              </a:rPr>
+              <a:t>Boulangerie Lomoto — Guide Chargé des commandes</a:t>
+            </a:r>
+            <a:endParaRPr lang="en-US" sz="950" dirty="0"/>
+          </a:p>
+        </p:txBody>
+      </p:sp>
+    </p:spTree>
+  </p:cSld>
+  <p:clrMapOvr>
+    <a:masterClrMapping/>
+  </p:clrMapOvr>
+</p:sld>
+</file>
+
+<file path=ppt/slides/slide15.xml><?xml version="1.0" encoding="utf-8"?>
+<p:sld xmlns:a="http://schemas.openxmlformats.org/drawingml/2006/main" xmlns:r="http://schemas.openxmlformats.org/officeDocument/2006/relationships" xmlns:p="http://schemas.openxmlformats.org/presentationml/2006/main">
+  <p:cSld name="Slide 9">
+    <p:bg>
+      <p:bgPr>
+        <a:solidFill>
+          <a:srgbClr val="FAF8F3"/>
+        </a:solidFill>
+      </p:bgPr>
+    </p:bg>
+    <p:spTree>
+      <p:nvGrpSpPr>
+        <p:cNvPr id="1" name=""/>
+        <p:cNvGrpSpPr/>
+        <p:nvPr/>
+      </p:nvGrpSpPr>
+      <p:grpSpPr>
+        <a:xfrm>
+          <a:off x="0" y="0"/>
+          <a:ext cx="0" cy="0"/>
+          <a:chOff x="0" y="0"/>
+          <a:chExt cx="0" cy="0"/>
+        </a:xfrm>
+      </p:grpSpPr>
+      <p:sp>
+        <p:nvSpPr>
+          <p:cNvPr id="2" name="Text 0"/>
+          <p:cNvSpPr/>
+          <p:nvPr/>
+        </p:nvSpPr>
+        <p:spPr>
+          <a:xfrm>
+            <a:off x="502920" y="384048"/>
+            <a:ext cx="7315200" cy="320040"/>
+          </a:xfrm>
+          <a:prstGeom prst="rect">
+            <a:avLst/>
+          </a:prstGeom>
+          <a:noFill/>
+          <a:ln/>
+        </p:spPr>
+        <p:txBody>
+          <a:bodyPr wrap="square" lIns="0" tIns="0" rIns="0" bIns="0" rtlCol="0" anchor="ctr"/>
+          <a:lstStyle/>
+          <a:p>
+            <a:pPr indent="0" marL="0">
+              <a:buNone/>
+            </a:pPr>
+            <a:r>
+              <a:rPr lang="en-US" sz="1200" b="1" spc="200" kern="0" dirty="0">
+                <a:solidFill>
+                  <a:srgbClr val="AD5416"/>
+                </a:solidFill>
+                <a:latin typeface="Calibri" pitchFamily="34" charset="0"/>
+                <a:ea typeface="Calibri" pitchFamily="34" charset="-122"/>
+                <a:cs typeface="Calibri" pitchFamily="34" charset="-120"/>
+              </a:rPr>
+              <a:t>SOUS-MODULE DE COMMANDES</a:t>
+            </a:r>
+            <a:endParaRPr lang="en-US" sz="1200" dirty="0"/>
+          </a:p>
+        </p:txBody>
+      </p:sp>
+      <p:sp>
+        <p:nvSpPr>
+          <p:cNvPr id="3" name="Text 1"/>
+          <p:cNvSpPr/>
+          <p:nvPr/>
+        </p:nvSpPr>
+        <p:spPr>
+          <a:xfrm>
+            <a:off x="502920" y="658368"/>
+            <a:ext cx="5394960" cy="960120"/>
+          </a:xfrm>
+          <a:prstGeom prst="rect">
+            <a:avLst/>
+          </a:prstGeom>
+          <a:noFill/>
+          <a:ln/>
+        </p:spPr>
+        <p:txBody>
+          <a:bodyPr wrap="square" lIns="0" tIns="0" rIns="0" bIns="0" rtlCol="0" anchor="ctr"/>
+          <a:lstStyle/>
+          <a:p>
+            <a:pPr indent="0" marL="0">
+              <a:buNone/>
+            </a:pPr>
+            <a:r>
+              <a:rPr lang="en-US" sz="2600" b="1" dirty="0">
+                <a:solidFill>
+                  <a:srgbClr val="0F1923"/>
+                </a:solidFill>
+                <a:latin typeface="Cambria" pitchFamily="34" charset="0"/>
+                <a:ea typeface="Cambria" pitchFamily="34" charset="-122"/>
+                <a:cs typeface="Cambria" pitchFamily="34" charset="-120"/>
+              </a:rPr>
+              <a:t>Gérer les clients</a:t>
+            </a:r>
+            <a:endParaRPr lang="en-US" sz="2600" dirty="0"/>
+          </a:p>
+        </p:txBody>
+      </p:sp>
+      <p:sp>
+        <p:nvSpPr>
+          <p:cNvPr id="4" name="Shape 2"/>
+          <p:cNvSpPr/>
+          <p:nvPr/>
+        </p:nvSpPr>
+        <p:spPr>
+          <a:xfrm>
+            <a:off x="502920" y="1691640"/>
+            <a:ext cx="1371600" cy="329184"/>
+          </a:xfrm>
+          <a:prstGeom prst="roundRect">
+            <a:avLst>
+              <a:gd name="adj" fmla="val 50000"/>
+            </a:avLst>
+          </a:prstGeom>
+          <a:solidFill>
+            <a:srgbClr val="DA9F4E"/>
+          </a:solidFill>
+          <a:ln/>
+        </p:spPr>
+      </p:sp>
+      <p:sp>
+        <p:nvSpPr>
+          <p:cNvPr id="5" name="Text 3"/>
+          <p:cNvSpPr/>
+          <p:nvPr/>
+        </p:nvSpPr>
+        <p:spPr>
+          <a:xfrm>
+            <a:off x="502920" y="1691640"/>
+            <a:ext cx="1371600" cy="329184"/>
+          </a:xfrm>
+          <a:prstGeom prst="rect">
+            <a:avLst/>
+          </a:prstGeom>
+          <a:noFill/>
+          <a:ln/>
+        </p:spPr>
+        <p:txBody>
+          <a:bodyPr wrap="square" lIns="0" tIns="0" rIns="0" bIns="0" rtlCol="0" anchor="ctr"/>
+          <a:lstStyle/>
+          <a:p>
+            <a:pPr algn="ctr" indent="0" marL="0">
+              <a:buNone/>
+            </a:pPr>
+            <a:r>
+              <a:rPr lang="en-US" sz="1050" b="1" dirty="0">
+                <a:solidFill>
+                  <a:srgbClr val="FFFFFF"/>
+                </a:solidFill>
+                <a:latin typeface="Calibri" pitchFamily="34" charset="0"/>
+                <a:ea typeface="Calibri" pitchFamily="34" charset="-122"/>
+                <a:cs typeface="Calibri" pitchFamily="34" charset="-120"/>
+              </a:rPr>
+              <a:t>Écriture</a:t>
+            </a:r>
+            <a:endParaRPr lang="en-US" sz="1050" dirty="0"/>
+          </a:p>
+        </p:txBody>
+      </p:sp>
+      <p:sp>
+        <p:nvSpPr>
+          <p:cNvPr id="6" name="Text 4"/>
+          <p:cNvSpPr/>
+          <p:nvPr/>
+        </p:nvSpPr>
+        <p:spPr>
+          <a:xfrm>
+            <a:off x="502920" y="2240280"/>
+            <a:ext cx="5120640" cy="3931920"/>
+          </a:xfrm>
+          <a:prstGeom prst="rect">
+            <a:avLst/>
+          </a:prstGeom>
+          <a:noFill/>
+          <a:ln/>
+        </p:spPr>
+        <p:txBody>
+          <a:bodyPr wrap="square" lIns="0" tIns="0" rIns="0" bIns="0" rtlCol="0" anchor="t"/>
+          <a:lstStyle/>
+          <a:p>
+            <a:pPr indent="0" marL="0">
+              <a:lnSpc>
+                <a:spcPct val="122000"/>
+              </a:lnSpc>
+              <a:spcAft>
+                <a:spcPts val="1400"/>
+              </a:spcAft>
+              <a:buNone/>
+            </a:pPr>
+            <a:r>
+              <a:rPr lang="en-US" sz="1300" dirty="0">
+                <a:solidFill>
+                  <a:srgbClr val="2C3644"/>
+                </a:solidFill>
+                <a:latin typeface="Calibri" pitchFamily="34" charset="0"/>
+                <a:ea typeface="Calibri" pitchFamily="34" charset="-122"/>
+                <a:cs typeface="Calibri" pitchFamily="34" charset="-120"/>
+              </a:rPr>
+              <a:t>Le bouton « Gérer les clients », en haut de l'écran Commandes, ouvre un écran à part avec la liste complète de vos clients — pour ne pas encombrer la saisie quotidienne des commandes.</a:t>
+            </a:r>
+            <a:endParaRPr lang="en-US" sz="1300" dirty="0"/>
+          </a:p>
+          <a:p>
+            <a:pPr indent="0" marL="0">
+              <a:lnSpc>
+                <a:spcPct val="122000"/>
+              </a:lnSpc>
+              <a:spcAft>
+                <a:spcPts val="1400"/>
+              </a:spcAft>
+              <a:buNone/>
+            </a:pPr>
+            <a:r>
+              <a:rPr lang="en-US" sz="1300" dirty="0">
+                <a:solidFill>
+                  <a:srgbClr val="2C3644"/>
+                </a:solidFill>
+                <a:latin typeface="Calibri" pitchFamily="34" charset="0"/>
+                <a:ea typeface="Calibri" pitchFamily="34" charset="-122"/>
+                <a:cs typeface="Calibri" pitchFamily="34" charset="-120"/>
+              </a:rPr>
+              <a:t>Chaque ligne affiche le téléphone, la qualité (Dépositaire, Maman, VC) et, pour les Dépositaires, la zone de dépôt utilisée dans le Schéma de commande du Responsable de production.</a:t>
+            </a:r>
+            <a:endParaRPr lang="en-US" sz="1300" dirty="0"/>
+          </a:p>
+        </p:txBody>
+      </p:sp>
+      <p:sp>
+        <p:nvSpPr>
+          <p:cNvPr id="7" name="Shape 5"/>
+          <p:cNvSpPr/>
+          <p:nvPr/>
+        </p:nvSpPr>
+        <p:spPr>
+          <a:xfrm>
+            <a:off x="502920" y="4590288"/>
+            <a:ext cx="82296" cy="82296"/>
+          </a:xfrm>
+          <a:prstGeom prst="ellipse">
+            <a:avLst/>
+          </a:prstGeom>
+          <a:solidFill>
+            <a:srgbClr val="AD5416"/>
+          </a:solidFill>
+          <a:ln/>
+        </p:spPr>
+      </p:sp>
+      <p:sp>
+        <p:nvSpPr>
+          <p:cNvPr id="8" name="Text 6"/>
+          <p:cNvSpPr/>
+          <p:nvPr/>
+        </p:nvSpPr>
+        <p:spPr>
+          <a:xfrm>
+            <a:off x="722376" y="4526280"/>
+            <a:ext cx="4937760" cy="365760"/>
+          </a:xfrm>
+          <a:prstGeom prst="rect">
+            <a:avLst/>
+          </a:prstGeom>
+          <a:noFill/>
+          <a:ln/>
+        </p:spPr>
+        <p:txBody>
+          <a:bodyPr wrap="square" lIns="0" tIns="0" rIns="0" bIns="0" rtlCol="0" anchor="ctr"/>
+          <a:lstStyle/>
+          <a:p>
+            <a:pPr indent="0" marL="0">
+              <a:buNone/>
+            </a:pPr>
+            <a:r>
+              <a:rPr lang="en-US" sz="1250" dirty="0">
+                <a:solidFill>
+                  <a:srgbClr val="2C3644"/>
+                </a:solidFill>
+                <a:latin typeface="Calibri" pitchFamily="34" charset="0"/>
+                <a:ea typeface="Calibri" pitchFamily="34" charset="-122"/>
+                <a:cs typeface="Calibri" pitchFamily="34" charset="-120"/>
+              </a:rPr>
+              <a:t>Rechercher un client par nom, en temps réel</a:t>
+            </a:r>
+            <a:endParaRPr lang="en-US" sz="1250" dirty="0"/>
+          </a:p>
+        </p:txBody>
+      </p:sp>
+      <p:sp>
+        <p:nvSpPr>
+          <p:cNvPr id="9" name="Shape 7"/>
+          <p:cNvSpPr/>
+          <p:nvPr/>
+        </p:nvSpPr>
+        <p:spPr>
+          <a:xfrm>
+            <a:off x="502920" y="4992624"/>
+            <a:ext cx="82296" cy="82296"/>
+          </a:xfrm>
+          <a:prstGeom prst="ellipse">
+            <a:avLst/>
+          </a:prstGeom>
+          <a:solidFill>
+            <a:srgbClr val="AD5416"/>
+          </a:solidFill>
+          <a:ln/>
+        </p:spPr>
+      </p:sp>
+      <p:sp>
+        <p:nvSpPr>
+          <p:cNvPr id="10" name="Text 8"/>
+          <p:cNvSpPr/>
+          <p:nvPr/>
+        </p:nvSpPr>
+        <p:spPr>
+          <a:xfrm>
+            <a:off x="722376" y="4928616"/>
+            <a:ext cx="4937760" cy="365760"/>
+          </a:xfrm>
+          <a:prstGeom prst="rect">
+            <a:avLst/>
+          </a:prstGeom>
+          <a:noFill/>
+          <a:ln/>
+        </p:spPr>
+        <p:txBody>
+          <a:bodyPr wrap="square" lIns="0" tIns="0" rIns="0" bIns="0" rtlCol="0" anchor="ctr"/>
+          <a:lstStyle/>
+          <a:p>
+            <a:pPr indent="0" marL="0">
+              <a:buNone/>
+            </a:pPr>
+            <a:r>
+              <a:rPr lang="en-US" sz="1250" dirty="0">
+                <a:solidFill>
+                  <a:srgbClr val="2C3644"/>
+                </a:solidFill>
+                <a:latin typeface="Calibri" pitchFamily="34" charset="0"/>
+                <a:ea typeface="Calibri" pitchFamily="34" charset="-122"/>
+                <a:cs typeface="Calibri" pitchFamily="34" charset="-120"/>
+              </a:rPr>
+              <a:t>Suppression bloquée si le client a déjà des commandes</a:t>
+            </a:r>
+            <a:endParaRPr lang="en-US" sz="1250" dirty="0"/>
+          </a:p>
+        </p:txBody>
+      </p:sp>
+      <p:sp>
+        <p:nvSpPr>
+          <p:cNvPr id="11" name="Shape 9"/>
+          <p:cNvSpPr/>
+          <p:nvPr/>
+        </p:nvSpPr>
+        <p:spPr>
+          <a:xfrm>
+            <a:off x="6080760" y="2080260"/>
+            <a:ext cx="5669280" cy="3611880"/>
+          </a:xfrm>
+          <a:prstGeom prst="roundRect">
+            <a:avLst>
+              <a:gd name="adj" fmla="val 1519"/>
+            </a:avLst>
+          </a:prstGeom>
+          <a:solidFill>
+            <a:srgbClr val="FFFFFF"/>
+          </a:solidFill>
+          <a:ln w="12700">
+            <a:solidFill>
+              <a:srgbClr val="CBAF91"/>
+            </a:solidFill>
+            <a:prstDash val="solid"/>
+          </a:ln>
+          <a:effectLst>
+            <a:outerShdw sx="100000" sy="100000" kx="0" ky="0" algn="bl" rotWithShape="0" blurRad="127000" dist="50800" dir="5400000">
+              <a:srgbClr val="000000">
+                <a:alpha val="28000"/>
+              </a:srgbClr>
+            </a:outerShdw>
+          </a:effectLst>
+        </p:spPr>
+      </p:sp>
+      <p:pic>
+        <p:nvPicPr>
+          <p:cNvPr id="12" name="Image 0" descr="/tmp/claude-0/-home-user-Boulangerie/f122e8ab-b408-5ce6-930c-e0c5bddf9e4c/scratchpad/captures/chargedescommandes/12-clients-liste.png">    </p:cNvPr>
+          <p:cNvPicPr>
+            <a:picLocks noChangeAspect="1"/>
+          </p:cNvPicPr>
+          <p:nvPr/>
+        </p:nvPicPr>
+        <p:blipFill>
+          <a:blip r:embed="rId1"/>
+          <a:stretch>
+            <a:fillRect/>
+          </a:stretch>
+        </p:blipFill>
+        <p:spPr>
+          <a:xfrm>
+            <a:off x="6421582" y="2171700"/>
+            <a:ext cx="4987636" cy="3429000"/>
+          </a:xfrm>
+          <a:prstGeom prst="rect">
+            <a:avLst/>
+          </a:prstGeom>
+        </p:spPr>
+      </p:pic>
+      <p:sp>
+        <p:nvSpPr>
+          <p:cNvPr id="13" name="Text 10"/>
+          <p:cNvSpPr/>
+          <p:nvPr/>
+        </p:nvSpPr>
+        <p:spPr>
+          <a:xfrm>
+            <a:off x="502920" y="6400800"/>
+            <a:ext cx="11185855" cy="292608"/>
+          </a:xfrm>
+          <a:prstGeom prst="rect">
+            <a:avLst/>
+          </a:prstGeom>
+          <a:noFill/>
+          <a:ln/>
+        </p:spPr>
+        <p:txBody>
+          <a:bodyPr wrap="square" lIns="0" tIns="0" rIns="0" bIns="0" rtlCol="0" anchor="ctr"/>
+          <a:lstStyle/>
+          <a:p>
+            <a:pPr algn="l" indent="0" marL="0">
+              <a:buNone/>
+            </a:pPr>
+            <a:r>
+              <a:rPr lang="en-US" sz="950" dirty="0">
+                <a:solidFill>
+                  <a:srgbClr val="A9A196"/>
+                </a:solidFill>
+                <a:latin typeface="Calibri" pitchFamily="34" charset="0"/>
+                <a:ea typeface="Calibri" pitchFamily="34" charset="-122"/>
+                <a:cs typeface="Calibri" pitchFamily="34" charset="-120"/>
+              </a:rPr>
+              <a:t>9 / 16</a:t>
+            </a:r>
+            <a:endParaRPr lang="en-US" sz="950" dirty="0"/>
+          </a:p>
+        </p:txBody>
+      </p:sp>
+      <p:sp>
+        <p:nvSpPr>
+          <p:cNvPr id="14" name="Text 11"/>
+          <p:cNvSpPr/>
+          <p:nvPr/>
+        </p:nvSpPr>
+        <p:spPr>
+          <a:xfrm>
+            <a:off x="502920" y="6400800"/>
+            <a:ext cx="11185855" cy="292608"/>
+          </a:xfrm>
+          <a:prstGeom prst="rect">
+            <a:avLst/>
+          </a:prstGeom>
+          <a:noFill/>
+          <a:ln/>
+        </p:spPr>
+        <p:txBody>
+          <a:bodyPr wrap="square" lIns="0" tIns="0" rIns="0" bIns="0" rtlCol="0" anchor="ctr"/>
+          <a:lstStyle/>
+          <a:p>
+            <a:pPr algn="r" indent="0" marL="0">
+              <a:buNone/>
+            </a:pPr>
+            <a:r>
+              <a:rPr lang="en-US" sz="950" dirty="0">
+                <a:solidFill>
+                  <a:srgbClr val="A9A196"/>
+                </a:solidFill>
+                <a:latin typeface="Calibri" pitchFamily="34" charset="0"/>
+                <a:ea typeface="Calibri" pitchFamily="34" charset="-122"/>
+                <a:cs typeface="Calibri" pitchFamily="34" charset="-120"/>
+              </a:rPr>
+              <a:t>Boulangerie Lomoto — Guide Chargé des commandes</a:t>
+            </a:r>
+            <a:endParaRPr lang="en-US" sz="950" dirty="0"/>
+          </a:p>
+        </p:txBody>
+      </p:sp>
+    </p:spTree>
+  </p:cSld>
+  <p:clrMapOvr>
+    <a:masterClrMapping/>
+  </p:clrMapOvr>
+</p:sld>
+</file>
+
+<file path=ppt/slides/slide16.xml><?xml version="1.0" encoding="utf-8"?>
+<p:sld xmlns:a="http://schemas.openxmlformats.org/drawingml/2006/main" xmlns:r="http://schemas.openxmlformats.org/officeDocument/2006/relationships" xmlns:p="http://schemas.openxmlformats.org/presentationml/2006/main">
+  <p:cSld name="Slide 9">
+    <p:bg>
+      <p:bgPr>
+        <a:solidFill>
+          <a:srgbClr val="FAF8F3"/>
+        </a:solidFill>
+      </p:bgPr>
+    </p:bg>
+    <p:spTree>
+      <p:nvGrpSpPr>
+        <p:cNvPr id="1" name=""/>
+        <p:cNvGrpSpPr/>
+        <p:nvPr/>
+      </p:nvGrpSpPr>
+      <p:grpSpPr>
+        <a:xfrm>
+          <a:off x="0" y="0"/>
+          <a:ext cx="0" cy="0"/>
+          <a:chOff x="0" y="0"/>
+          <a:chExt cx="0" cy="0"/>
+        </a:xfrm>
+      </p:grpSpPr>
+      <p:sp>
+        <p:nvSpPr>
+          <p:cNvPr id="2" name="Text 0"/>
+          <p:cNvSpPr/>
+          <p:nvPr/>
+        </p:nvSpPr>
+        <p:spPr>
+          <a:xfrm>
+            <a:off x="502920" y="384048"/>
+            <a:ext cx="7315200" cy="320040"/>
+          </a:xfrm>
+          <a:prstGeom prst="rect">
+            <a:avLst/>
+          </a:prstGeom>
+          <a:noFill/>
+          <a:ln/>
+        </p:spPr>
+        <p:txBody>
+          <a:bodyPr wrap="square" lIns="0" tIns="0" rIns="0" bIns="0" rtlCol="0" anchor="ctr"/>
+          <a:lstStyle/>
+          <a:p>
+            <a:pPr indent="0" marL="0">
+              <a:buNone/>
+            </a:pPr>
+            <a:r>
+              <a:rPr lang="en-US" sz="1200" b="1" spc="200" kern="0" dirty="0">
+                <a:solidFill>
+                  <a:srgbClr val="AD5416"/>
+                </a:solidFill>
+                <a:latin typeface="Calibri" pitchFamily="34" charset="0"/>
+                <a:ea typeface="Calibri" pitchFamily="34" charset="-122"/>
+                <a:cs typeface="Calibri" pitchFamily="34" charset="-120"/>
+              </a:rPr>
+              <a:t>SOUS-MODULE DE COMMANDES</a:t>
+            </a:r>
+            <a:endParaRPr lang="en-US" sz="1200" dirty="0"/>
+          </a:p>
+        </p:txBody>
+      </p:sp>
+      <p:sp>
+        <p:nvSpPr>
+          <p:cNvPr id="3" name="Text 1"/>
+          <p:cNvSpPr/>
+          <p:nvPr/>
+        </p:nvSpPr>
+        <p:spPr>
+          <a:xfrm>
+            <a:off x="502920" y="658368"/>
+            <a:ext cx="5394960" cy="960120"/>
+          </a:xfrm>
+          <a:prstGeom prst="rect">
+            <a:avLst/>
+          </a:prstGeom>
+          <a:noFill/>
+          <a:ln/>
+        </p:spPr>
+        <p:txBody>
+          <a:bodyPr wrap="square" lIns="0" tIns="0" rIns="0" bIns="0" rtlCol="0" anchor="ctr"/>
+          <a:lstStyle/>
+          <a:p>
+            <a:pPr indent="0" marL="0">
+              <a:buNone/>
+            </a:pPr>
+            <a:r>
+              <a:rPr lang="en-US" sz="2600" b="1" dirty="0">
+                <a:solidFill>
+                  <a:srgbClr val="0F1923"/>
+                </a:solidFill>
+                <a:latin typeface="Cambria" pitchFamily="34" charset="0"/>
+                <a:ea typeface="Cambria" pitchFamily="34" charset="-122"/>
+                <a:cs typeface="Cambria" pitchFamily="34" charset="-120"/>
+              </a:rPr>
+              <a:t>Modifier un client : la zone de dépôt</a:t>
+            </a:r>
+            <a:endParaRPr lang="en-US" sz="2600" dirty="0"/>
+          </a:p>
+        </p:txBody>
+      </p:sp>
+      <p:sp>
+        <p:nvSpPr>
+          <p:cNvPr id="4" name="Shape 2"/>
+          <p:cNvSpPr/>
+          <p:nvPr/>
+        </p:nvSpPr>
+        <p:spPr>
+          <a:xfrm>
+            <a:off x="502920" y="1691640"/>
+            <a:ext cx="1371600" cy="329184"/>
+          </a:xfrm>
+          <a:prstGeom prst="roundRect">
+            <a:avLst>
+              <a:gd name="adj" fmla="val 50000"/>
+            </a:avLst>
+          </a:prstGeom>
+          <a:solidFill>
+            <a:srgbClr val="DA9F4E"/>
+          </a:solidFill>
+          <a:ln/>
+        </p:spPr>
+      </p:sp>
+      <p:sp>
+        <p:nvSpPr>
+          <p:cNvPr id="5" name="Text 3"/>
+          <p:cNvSpPr/>
+          <p:nvPr/>
+        </p:nvSpPr>
+        <p:spPr>
+          <a:xfrm>
+            <a:off x="502920" y="1691640"/>
+            <a:ext cx="1371600" cy="329184"/>
+          </a:xfrm>
+          <a:prstGeom prst="rect">
+            <a:avLst/>
+          </a:prstGeom>
+          <a:noFill/>
+          <a:ln/>
+        </p:spPr>
+        <p:txBody>
+          <a:bodyPr wrap="square" lIns="0" tIns="0" rIns="0" bIns="0" rtlCol="0" anchor="ctr"/>
+          <a:lstStyle/>
+          <a:p>
+            <a:pPr algn="ctr" indent="0" marL="0">
+              <a:buNone/>
+            </a:pPr>
+            <a:r>
+              <a:rPr lang="en-US" sz="1050" b="1" dirty="0">
+                <a:solidFill>
+                  <a:srgbClr val="FFFFFF"/>
+                </a:solidFill>
+                <a:latin typeface="Calibri" pitchFamily="34" charset="0"/>
+                <a:ea typeface="Calibri" pitchFamily="34" charset="-122"/>
+                <a:cs typeface="Calibri" pitchFamily="34" charset="-120"/>
+              </a:rPr>
+              <a:t>Écriture</a:t>
+            </a:r>
+            <a:endParaRPr lang="en-US" sz="1050" dirty="0"/>
+          </a:p>
+        </p:txBody>
+      </p:sp>
+      <p:sp>
+        <p:nvSpPr>
+          <p:cNvPr id="6" name="Text 4"/>
+          <p:cNvSpPr/>
+          <p:nvPr/>
+        </p:nvSpPr>
+        <p:spPr>
+          <a:xfrm>
+            <a:off x="502920" y="2240280"/>
+            <a:ext cx="5120640" cy="3931920"/>
+          </a:xfrm>
+          <a:prstGeom prst="rect">
+            <a:avLst/>
+          </a:prstGeom>
+          <a:noFill/>
+          <a:ln/>
+        </p:spPr>
+        <p:txBody>
+          <a:bodyPr wrap="square" lIns="0" tIns="0" rIns="0" bIns="0" rtlCol="0" anchor="t"/>
+          <a:lstStyle/>
+          <a:p>
+            <a:pPr indent="0" marL="0">
+              <a:lnSpc>
+                <a:spcPct val="122000"/>
+              </a:lnSpc>
+              <a:spcAft>
+                <a:spcPts val="1400"/>
+              </a:spcAft>
+              <a:buNone/>
+            </a:pPr>
+            <a:r>
+              <a:rPr lang="en-US" sz="1300" dirty="0">
+                <a:solidFill>
+                  <a:srgbClr val="2C3644"/>
+                </a:solidFill>
+                <a:latin typeface="Calibri" pitchFamily="34" charset="0"/>
+                <a:ea typeface="Calibri" pitchFamily="34" charset="-122"/>
+                <a:cs typeface="Calibri" pitchFamily="34" charset="-120"/>
+              </a:rPr>
+              <a:t>En modifiant un client Dépositaire, une liste déroulante « Zone de dépôt » apparaît — un simple regroupement géographique (aucun effet sur le prix ni la commission), utilisé pour trier l'affichage du Schéma de commande par tournée.</a:t>
+            </a:r>
+            <a:endParaRPr lang="en-US" sz="1300" dirty="0"/>
+          </a:p>
+          <a:p>
+            <a:pPr indent="0" marL="0">
+              <a:lnSpc>
+                <a:spcPct val="122000"/>
+              </a:lnSpc>
+              <a:spcAft>
+                <a:spcPts val="1400"/>
+              </a:spcAft>
+              <a:buNone/>
+            </a:pPr>
+            <a:r>
+              <a:rPr lang="en-US" sz="1300" dirty="0">
+                <a:solidFill>
+                  <a:srgbClr val="2C3644"/>
+                </a:solidFill>
+                <a:latin typeface="Calibri" pitchFamily="34" charset="0"/>
+                <a:ea typeface="Calibri" pitchFamily="34" charset="-122"/>
+                <a:cs typeface="Calibri" pitchFamily="34" charset="-120"/>
+              </a:rPr>
+              <a:t>Si la zone dont vous avez besoin n'existe pas encore, elle doit être créée depuis l'écran Production par le Responsable de production ou un Administrateur — vous pourrez alors l'assigner ici en un clic.</a:t>
+            </a:r>
+            <a:endParaRPr lang="en-US" sz="1300" dirty="0"/>
+          </a:p>
+        </p:txBody>
+      </p:sp>
+      <p:sp>
+        <p:nvSpPr>
+          <p:cNvPr id="7" name="Shape 5"/>
+          <p:cNvSpPr/>
+          <p:nvPr/>
+        </p:nvSpPr>
+        <p:spPr>
+          <a:xfrm>
+            <a:off x="502920" y="4590288"/>
+            <a:ext cx="82296" cy="82296"/>
+          </a:xfrm>
+          <a:prstGeom prst="ellipse">
+            <a:avLst/>
+          </a:prstGeom>
+          <a:solidFill>
+            <a:srgbClr val="AD5416"/>
+          </a:solidFill>
+          <a:ln/>
+        </p:spPr>
+      </p:sp>
+      <p:sp>
+        <p:nvSpPr>
+          <p:cNvPr id="8" name="Text 6"/>
+          <p:cNvSpPr/>
+          <p:nvPr/>
+        </p:nvSpPr>
+        <p:spPr>
+          <a:xfrm>
+            <a:off x="722376" y="4526280"/>
+            <a:ext cx="4937760" cy="365760"/>
+          </a:xfrm>
+          <a:prstGeom prst="rect">
+            <a:avLst/>
+          </a:prstGeom>
+          <a:noFill/>
+          <a:ln/>
+        </p:spPr>
+        <p:txBody>
+          <a:bodyPr wrap="square" lIns="0" tIns="0" rIns="0" bIns="0" rtlCol="0" anchor="ctr"/>
+          <a:lstStyle/>
+          <a:p>
+            <a:pPr indent="0" marL="0">
+              <a:buNone/>
+            </a:pPr>
+            <a:r>
+              <a:rPr lang="en-US" sz="1250" dirty="0">
+                <a:solidFill>
+                  <a:srgbClr val="2C3644"/>
+                </a:solidFill>
+                <a:latin typeface="Calibri" pitchFamily="34" charset="0"/>
+                <a:ea typeface="Calibri" pitchFamily="34" charset="-122"/>
+                <a:cs typeface="Calibri" pitchFamily="34" charset="-120"/>
+              </a:rPr>
+              <a:t>Un Dépositaire peut rester « Sans zone », sans conséquence</a:t>
+            </a:r>
+            <a:endParaRPr lang="en-US" sz="1250" dirty="0"/>
+          </a:p>
+        </p:txBody>
+      </p:sp>
+      <p:sp>
+        <p:nvSpPr>
+          <p:cNvPr id="9" name="Shape 7"/>
+          <p:cNvSpPr/>
+          <p:nvPr/>
+        </p:nvSpPr>
+        <p:spPr>
+          <a:xfrm>
+            <a:off x="502920" y="4992624"/>
+            <a:ext cx="82296" cy="82296"/>
+          </a:xfrm>
+          <a:prstGeom prst="ellipse">
+            <a:avLst/>
+          </a:prstGeom>
+          <a:solidFill>
+            <a:srgbClr val="AD5416"/>
+          </a:solidFill>
+          <a:ln/>
+        </p:spPr>
+      </p:sp>
+      <p:sp>
+        <p:nvSpPr>
+          <p:cNvPr id="10" name="Text 8"/>
+          <p:cNvSpPr/>
+          <p:nvPr/>
+        </p:nvSpPr>
+        <p:spPr>
+          <a:xfrm>
+            <a:off x="722376" y="4928616"/>
+            <a:ext cx="4937760" cy="365760"/>
+          </a:xfrm>
+          <a:prstGeom prst="rect">
+            <a:avLst/>
+          </a:prstGeom>
+          <a:noFill/>
+          <a:ln/>
+        </p:spPr>
+        <p:txBody>
+          <a:bodyPr wrap="square" lIns="0" tIns="0" rIns="0" bIns="0" rtlCol="0" anchor="ctr"/>
+          <a:lstStyle/>
+          <a:p>
+            <a:pPr indent="0" marL="0">
+              <a:buNone/>
+            </a:pPr>
+            <a:r>
+              <a:rPr lang="en-US" sz="1250" dirty="0">
+                <a:solidFill>
+                  <a:srgbClr val="2C3644"/>
+                </a:solidFill>
+                <a:latin typeface="Calibri" pitchFamily="34" charset="0"/>
+                <a:ea typeface="Calibri" pitchFamily="34" charset="-122"/>
+                <a:cs typeface="Calibri" pitchFamily="34" charset="-120"/>
+              </a:rPr>
+              <a:t>La zone n'a aucun effet sur le calcul de la commande</a:t>
+            </a:r>
+            <a:endParaRPr lang="en-US" sz="1250" dirty="0"/>
+          </a:p>
+        </p:txBody>
+      </p:sp>
+      <p:sp>
+        <p:nvSpPr>
+          <p:cNvPr id="11" name="Shape 9"/>
+          <p:cNvSpPr/>
+          <p:nvPr/>
+        </p:nvSpPr>
+        <p:spPr>
+          <a:xfrm>
+            <a:off x="6080760" y="2080260"/>
+            <a:ext cx="5669280" cy="3611880"/>
+          </a:xfrm>
+          <a:prstGeom prst="roundRect">
+            <a:avLst>
+              <a:gd name="adj" fmla="val 1519"/>
+            </a:avLst>
+          </a:prstGeom>
+          <a:solidFill>
+            <a:srgbClr val="FFFFFF"/>
+          </a:solidFill>
+          <a:ln w="12700">
+            <a:solidFill>
+              <a:srgbClr val="CBAF91"/>
+            </a:solidFill>
+            <a:prstDash val="solid"/>
+          </a:ln>
+          <a:effectLst>
+            <a:outerShdw sx="100000" sy="100000" kx="0" ky="0" algn="bl" rotWithShape="0" blurRad="127000" dist="50800" dir="5400000">
+              <a:srgbClr val="000000">
+                <a:alpha val="28000"/>
+              </a:srgbClr>
+            </a:outerShdw>
+          </a:effectLst>
+        </p:spPr>
+      </p:sp>
+      <p:pic>
+        <p:nvPicPr>
+          <p:cNvPr id="12" name="Image 0" descr="/tmp/claude-0/-home-user-Boulangerie/f122e8ab-b408-5ce6-930c-e0c5bddf9e4c/scratchpad/captures/chargedescommandes/13-clients-dialog-modifier.png">    </p:cNvPr>
+          <p:cNvPicPr>
+            <a:picLocks noChangeAspect="1"/>
+          </p:cNvPicPr>
+          <p:nvPr/>
+        </p:nvPicPr>
+        <p:blipFill>
+          <a:blip r:embed="rId1"/>
+          <a:stretch>
+            <a:fillRect/>
+          </a:stretch>
+        </p:blipFill>
+        <p:spPr>
+          <a:xfrm>
+            <a:off x="6568277" y="2171700"/>
+            <a:ext cx="4694246" cy="3429000"/>
+          </a:xfrm>
+          <a:prstGeom prst="rect">
+            <a:avLst/>
+          </a:prstGeom>
+        </p:spPr>
+      </p:pic>
+      <p:sp>
+        <p:nvSpPr>
+          <p:cNvPr id="13" name="Text 10"/>
+          <p:cNvSpPr/>
+          <p:nvPr/>
+        </p:nvSpPr>
+        <p:spPr>
+          <a:xfrm>
+            <a:off x="502920" y="6400800"/>
+            <a:ext cx="11185855" cy="292608"/>
+          </a:xfrm>
+          <a:prstGeom prst="rect">
+            <a:avLst/>
+          </a:prstGeom>
+          <a:noFill/>
+          <a:ln/>
+        </p:spPr>
+        <p:txBody>
+          <a:bodyPr wrap="square" lIns="0" tIns="0" rIns="0" bIns="0" rtlCol="0" anchor="ctr"/>
+          <a:lstStyle/>
+          <a:p>
+            <a:pPr algn="l" indent="0" marL="0">
+              <a:buNone/>
+            </a:pPr>
+            <a:r>
+              <a:rPr lang="en-US" sz="950" dirty="0">
+                <a:solidFill>
+                  <a:srgbClr val="A9A196"/>
+                </a:solidFill>
+                <a:latin typeface="Calibri" pitchFamily="34" charset="0"/>
+                <a:ea typeface="Calibri" pitchFamily="34" charset="-122"/>
+                <a:cs typeface="Calibri" pitchFamily="34" charset="-120"/>
+              </a:rPr>
+              <a:t>10 / 16</a:t>
+            </a:r>
+            <a:endParaRPr lang="en-US" sz="950" dirty="0"/>
+          </a:p>
+        </p:txBody>
+      </p:sp>
+      <p:sp>
+        <p:nvSpPr>
+          <p:cNvPr id="14" name="Text 11"/>
+          <p:cNvSpPr/>
+          <p:nvPr/>
+        </p:nvSpPr>
+        <p:spPr>
+          <a:xfrm>
+            <a:off x="502920" y="6400800"/>
+            <a:ext cx="11185855" cy="292608"/>
+          </a:xfrm>
+          <a:prstGeom prst="rect">
+            <a:avLst/>
+          </a:prstGeom>
+          <a:noFill/>
+          <a:ln/>
+        </p:spPr>
+        <p:txBody>
+          <a:bodyPr wrap="square" lIns="0" tIns="0" rIns="0" bIns="0" rtlCol="0" anchor="ctr"/>
+          <a:lstStyle/>
+          <a:p>
+            <a:pPr algn="r" indent="0" marL="0">
+              <a:buNone/>
+            </a:pPr>
+            <a:r>
+              <a:rPr lang="en-US" sz="950" dirty="0">
+                <a:solidFill>
+                  <a:srgbClr val="A9A196"/>
                 </a:solidFill>
                 <a:latin typeface="Calibri" pitchFamily="34" charset="0"/>
                 <a:ea typeface="Calibri" pitchFamily="34" charset="-122"/>
@@ -6052,7 +7040,7 @@
                 <a:ea typeface="Calibri" pitchFamily="34" charset="-122"/>
                 <a:cs typeface="Calibri" pitchFamily="34" charset="-120"/>
               </a:rPr>
-              <a:t>2 / 14</a:t>
+              <a:t>2 / 16</a:t>
             </a:r>
             <a:endParaRPr lang="en-US" sz="950" dirty="0"/>
           </a:p>
@@ -7150,7 +8138,7 @@
                 <a:ea typeface="Calibri" pitchFamily="34" charset="-122"/>
                 <a:cs typeface="Calibri" pitchFamily="34" charset="-120"/>
               </a:rPr>
-              <a:t>3 / 14</a:t>
+              <a:t>3 / 16</a:t>
             </a:r>
             <a:endParaRPr lang="en-US" sz="950" dirty="0"/>
           </a:p>
@@ -7861,7 +8849,7 @@
                 <a:ea typeface="Calibri" pitchFamily="34" charset="-122"/>
                 <a:cs typeface="Calibri" pitchFamily="34" charset="-120"/>
               </a:rPr>
-              <a:t>4 / 14</a:t>
+              <a:t>4 / 16</a:t>
             </a:r>
             <a:endParaRPr lang="en-US" sz="950" dirty="0"/>
           </a:p>
@@ -8352,7 +9340,7 @@
                 <a:ea typeface="Calibri" pitchFamily="34" charset="-122"/>
                 <a:cs typeface="Calibri" pitchFamily="34" charset="-120"/>
               </a:rPr>
-              <a:t>5 / 14</a:t>
+              <a:t>5 / 16</a:t>
             </a:r>
             <a:endParaRPr lang="en-US" sz="950" dirty="0"/>
           </a:p>
@@ -8940,7 +9928,7 @@
                 <a:ea typeface="Calibri" pitchFamily="34" charset="-122"/>
                 <a:cs typeface="Calibri" pitchFamily="34" charset="-120"/>
               </a:rPr>
-              <a:t>6 / 14</a:t>
+              <a:t>6 / 16</a:t>
             </a:r>
             <a:endParaRPr lang="en-US" sz="950" dirty="0"/>
           </a:p>
@@ -9451,7 +10439,7 @@
                 <a:ea typeface="Calibri" pitchFamily="34" charset="-122"/>
                 <a:cs typeface="Calibri" pitchFamily="34" charset="-120"/>
               </a:rPr>
-              <a:t>7 / 14</a:t>
+              <a:t>7 / 16</a:t>
             </a:r>
             <a:endParaRPr lang="en-US" sz="950" dirty="0"/>
           </a:p>
@@ -9877,7 +10865,7 @@
                 <a:ea typeface="Calibri" pitchFamily="34" charset="-122"/>
                 <a:cs typeface="Calibri" pitchFamily="34" charset="-120"/>
               </a:rPr>
-              <a:t>8 / 14</a:t>
+              <a:t>8 / 16</a:t>
             </a:r>
             <a:endParaRPr lang="en-US" sz="950" dirty="0"/>
           </a:p>
@@ -10370,7 +11358,7 @@
                 <a:ea typeface="Calibri" pitchFamily="34" charset="-122"/>
                 <a:cs typeface="Calibri" pitchFamily="34" charset="-120"/>
               </a:rPr>
-              <a:t>9 / 14</a:t>
+              <a:t>11 / 16</a:t>
             </a:r>
             <a:endParaRPr lang="en-US" sz="950" dirty="0"/>
           </a:p>

</xml_diff>